<commit_message>
Plateau : dé révélateur, démo 3D, caméra qui suit, pions qui sautent, retardataires et cartes bonus, numérotation séquentielle des exercices
Co-Authored-By: Claude Sonnet 5.5 <noreply@anthropic.com>
Claude-Session: https://claude.ai/code/session_01V4iLjkQMq3VTwEC9VERxK9
</commit_message>
<xml_diff>
--- a/modele-dossier-etat-de-l-art.pptx
+++ b/modele-dossier-etat-de-l-art.pptx
@@ -5884,7 +5884,7 @@
                 </a:solidFill>
                 <a:latin typeface="Calibri"/>
               </a:rPr>
-              <a:t>À remplir à : EX13   ·   Objectif du syllabus : O3</a:t>
+              <a:t>À remplir à : EX11   ·   Objectif du syllabus : O3</a:t>
             </a:r>
           </a:p>
         </p:txBody>
@@ -6743,7 +6743,7 @@
                 </a:solidFill>
                 <a:latin typeface="Calibri"/>
               </a:rPr>
-              <a:t>À remplir à : EX14   ·   Objectif du syllabus : O2</a:t>
+              <a:t>À remplir à : EX12   ·   Objectif du syllabus : O2</a:t>
             </a:r>
           </a:p>
         </p:txBody>
@@ -7790,7 +7790,7 @@
                 </a:solidFill>
                 <a:latin typeface="Calibri"/>
               </a:rPr>
-              <a:t>À remplir à : EX15   ·   Objectif du syllabus : O2</a:t>
+              <a:t>À remplir à : EX13   ·   Objectif du syllabus : O2</a:t>
             </a:r>
           </a:p>
         </p:txBody>
@@ -10270,7 +10270,7 @@
                 </a:solidFill>
                 <a:latin typeface="Calibri"/>
               </a:rPr>
-              <a:t>À remplir à : EX16 et EX19   ·   Objectif du syllabus : O1</a:t>
+              <a:t>À remplir à : EX14 et EX17   ·   Objectif du syllabus : O1</a:t>
             </a:r>
           </a:p>
         </p:txBody>
@@ -11317,7 +11317,7 @@
                 </a:solidFill>
                 <a:latin typeface="Calibri"/>
               </a:rPr>
-              <a:t>À remplir à : EX18 et EX20   ·   Objectif du syllabus : O1</a:t>
+              <a:t>À remplir à : EX16 et EX18   ·   Objectif du syllabus : O1</a:t>
             </a:r>
           </a:p>
         </p:txBody>
@@ -12270,7 +12270,7 @@
                 </a:solidFill>
                 <a:latin typeface="Calibri"/>
               </a:rPr>
-              <a:t>À remplir à : EX21 et EX22   ·   Objectif du syllabus : P2</a:t>
+              <a:t>À remplir à : EX19 et EX20   ·   Objectif du syllabus : P2</a:t>
             </a:r>
           </a:p>
         </p:txBody>
@@ -15721,7 +15721,7 @@
                 </a:solidFill>
                 <a:latin typeface="Calibri"/>
               </a:rPr>
-              <a:t>À remplir à : EX23   ·   Objectif du syllabus : P2</a:t>
+              <a:t>À remplir à : EX21   ·   Objectif du syllabus : P2</a:t>
             </a:r>
           </a:p>
         </p:txBody>
@@ -16674,7 +16674,7 @@
                 </a:solidFill>
                 <a:latin typeface="Calibri"/>
               </a:rPr>
-              <a:t>À remplir à : EX24   ·   Objectif du syllabus : P2 et O1</a:t>
+              <a:t>À remplir à : EX22   ·   Objectif du syllabus : P2 et O1</a:t>
             </a:r>
           </a:p>
         </p:txBody>
@@ -17156,7 +17156,7 @@
                 </a:solidFill>
                 <a:latin typeface="Calibri"/>
               </a:rPr>
-              <a:t>À remplir à : EX25   ·   Objectif du syllabus : P2</a:t>
+              <a:t>À remplir à : EX23   ·   Objectif du syllabus : P2</a:t>
             </a:r>
           </a:p>
         </p:txBody>
@@ -18849,7 +18849,7 @@
                 </a:solidFill>
                 <a:latin typeface="Calibri"/>
               </a:rPr>
-              <a:t>À remplir à : EX26 et EX27   ·   Objectif du syllabus : P2</a:t>
+              <a:t>À remplir à : EX24 et EX25   ·   Objectif du syllabus : P2</a:t>
             </a:r>
           </a:p>
         </p:txBody>
@@ -21665,7 +21665,7 @@
                 </a:solidFill>
                 <a:latin typeface="Calibri"/>
               </a:rPr>
-              <a:t>À remplir à : EX10 (Zotero)   ·   Objectif du syllabus : P2</a:t>
+              <a:t>À remplir à : EX8 (Zotero)   ·   Objectif du syllabus : P2</a:t>
             </a:r>
           </a:p>
         </p:txBody>
@@ -28173,7 +28173,7 @@
                 </a:solidFill>
                 <a:latin typeface="Calibri"/>
               </a:rPr>
-              <a:t>À remplir à : V8 (et EX22)   ·   Objectif du syllabus : O3 et P2</a:t>
+              <a:t>À remplir à : V8 (et EX20)   ·   Objectif du syllabus : O3 et P2</a:t>
             </a:r>
           </a:p>
         </p:txBody>
@@ -35023,7 +35023,7 @@
                 </a:solidFill>
                 <a:latin typeface="Calibri"/>
               </a:rPr>
-              <a:t>À remplir à : EX7 et EX8   ·   Objectif du syllabus : O3</a:t>
+              <a:t>À remplir à : EX5 et EX6   ·   Objectif du syllabus : O3</a:t>
             </a:r>
           </a:p>
         </p:txBody>
@@ -37271,7 +37271,7 @@
                 </a:solidFill>
                 <a:latin typeface="Calibri"/>
               </a:rPr>
-              <a:t>À remplir à : EX9   ·   Objectif du syllabus : O3</a:t>
+              <a:t>À remplir à : EX7   ·   Objectif du syllabus : O3</a:t>
             </a:r>
           </a:p>
         </p:txBody>
@@ -39054,7 +39054,7 @@
                 </a:solidFill>
                 <a:latin typeface="Calibri"/>
               </a:rPr>
-              <a:t>À remplir à : EX10, EX11b, EX12   ·   Objectif du syllabus : O3</a:t>
+              <a:t>À remplir à : EX8, EX9, EX10   ·   Objectif du syllabus : O3</a:t>
             </a:r>
           </a:p>
         </p:txBody>

</xml_diff>